<commit_message>
Updated AI defintion slightly to include references to multimodality
</commit_message>
<xml_diff>
--- a/APPLIED_MECHANISTICS.pptx
+++ b/APPLIED_MECHANISTICS.pptx
@@ -107,6 +107,11 @@
       </a:defRPr>
     </a:lvl9pPr>
   </p:defaultTextStyle>
+  <p:extLst>
+    <p:ext uri="{EFAFB233-063F-42B5-8137-9DF3F51BA10A}">
+      <p15:sldGuideLst xmlns:p15="http://schemas.microsoft.com/office/powerpoint/2012/main"/>
+    </p:ext>
+  </p:extLst>
 </p:presentation>
 </file>
 
@@ -3543,8 +3548,8 @@
           <a:p>
             <a:pPr algn="ctr"/>
             <a:r>
-              <a:rPr lang="en-US" dirty="0"/>
-              <a:t>LLM Generates Python Code for Mesh</a:t>
+              <a:rPr lang="en-US" sz="1600" dirty="0"/>
+              <a:t>VLM Generates Python Code for Mesh</a:t>
             </a:r>
           </a:p>
         </p:txBody>
@@ -4342,6 +4347,46 @@
             <a:r>
               <a:rPr lang="en-US" dirty="0"/>
               <a:t>AM Pipeline</a:t>
+            </a:r>
+          </a:p>
+        </p:txBody>
+      </p:sp>
+      <p:sp>
+        <p:nvSpPr>
+          <p:cNvPr id="3" name="TextBox 2">
+            <a:extLst>
+              <a:ext uri="{FF2B5EF4-FFF2-40B4-BE49-F238E27FC236}">
+                <a16:creationId xmlns:a16="http://schemas.microsoft.com/office/drawing/2014/main" id="{59BFD3FD-78F5-F67A-286C-8D019C98191E}"/>
+              </a:ext>
+            </a:extLst>
+          </p:cNvPr>
+          <p:cNvSpPr txBox="1"/>
+          <p:nvPr/>
+        </p:nvSpPr>
+        <p:spPr>
+          <a:xfrm>
+            <a:off x="3983420" y="6043449"/>
+            <a:ext cx="4225159" cy="646331"/>
+          </a:xfrm>
+          <a:prstGeom prst="rect">
+            <a:avLst/>
+          </a:prstGeom>
+          <a:noFill/>
+        </p:spPr>
+        <p:txBody>
+          <a:bodyPr wrap="square" rtlCol="0">
+            <a:spAutoFit/>
+          </a:bodyPr>
+          <a:lstStyle/>
+          <a:p>
+            <a:pPr algn="ctr"/>
+            <a:r>
+              <a:rPr lang="en-US" dirty="0">
+                <a:highlight>
+                  <a:srgbClr val="FFFF00"/>
+                </a:highlight>
+              </a:rPr>
+              <a:t>VLM will be used instead of LLM because multimodality is essential</a:t>
             </a:r>
           </a:p>
         </p:txBody>

</xml_diff>